<commit_message>
Finish Ivan product manager deliverables
</commit_message>
<xml_diff>
--- a/output/presentation/PRESENTATION_FINAL_DRAFT.pptx
+++ b/output/presentation/PRESENTATION_FINAL_DRAFT.pptx
@@ -2,21 +2,21 @@
 <file path=ppt/presentation.xml><?xml version="1.0" encoding="utf-8"?>
 <p:presentation xmlns:p="http://schemas.openxmlformats.org/presentationml/2006/main">
   <p:sldMasterIdLst>
-    <p:sldMasterId xmlns:r="http://schemas.openxmlformats.org/officeDocument/2006/relationships" id="2147483648" r:id="R66f5ea74441441b5"/>
+    <p:sldMasterId xmlns:r="http://schemas.openxmlformats.org/officeDocument/2006/relationships" id="2147483648" r:id="R9727f1bd5e9445dd"/>
   </p:sldMasterIdLst>
   <p:notesMasterIdLst>
-    <p:notesMasterId xmlns:r="http://schemas.openxmlformats.org/officeDocument/2006/relationships" r:id="Rb3daab2e2aee42e5"/>
+    <p:notesMasterId xmlns:r="http://schemas.openxmlformats.org/officeDocument/2006/relationships" r:id="Ra3350f1650004ed0"/>
   </p:notesMasterIdLst>
   <p:sldIdLst>
-    <p:sldId xmlns:r="http://schemas.openxmlformats.org/officeDocument/2006/relationships" id="256" r:id="R4a2d64b4db7849f1"/>
-    <p:sldId xmlns:r="http://schemas.openxmlformats.org/officeDocument/2006/relationships" id="257" r:id="R4f4677607cc84860"/>
-    <p:sldId xmlns:r="http://schemas.openxmlformats.org/officeDocument/2006/relationships" id="258" r:id="R4eb991a76a234fdd"/>
-    <p:sldId xmlns:r="http://schemas.openxmlformats.org/officeDocument/2006/relationships" id="259" r:id="R071fab767c7f4dda"/>
-    <p:sldId xmlns:r="http://schemas.openxmlformats.org/officeDocument/2006/relationships" id="260" r:id="Rb6979ed21e1f421a"/>
-    <p:sldId xmlns:r="http://schemas.openxmlformats.org/officeDocument/2006/relationships" id="261" r:id="Rbab196433fdf4e5c"/>
-    <p:sldId xmlns:r="http://schemas.openxmlformats.org/officeDocument/2006/relationships" id="262" r:id="Rdfae6197a8f944bb"/>
-    <p:sldId xmlns:r="http://schemas.openxmlformats.org/officeDocument/2006/relationships" id="263" r:id="R7f43a0e3ef614423"/>
-    <p:sldId xmlns:r="http://schemas.openxmlformats.org/officeDocument/2006/relationships" id="264" r:id="R816abc85a6784e24"/>
+    <p:sldId xmlns:r="http://schemas.openxmlformats.org/officeDocument/2006/relationships" id="256" r:id="R4ababe62f92e4c91"/>
+    <p:sldId xmlns:r="http://schemas.openxmlformats.org/officeDocument/2006/relationships" id="257" r:id="Rca50d8dc36964eb3"/>
+    <p:sldId xmlns:r="http://schemas.openxmlformats.org/officeDocument/2006/relationships" id="258" r:id="R9529bd5deb3e4dca"/>
+    <p:sldId xmlns:r="http://schemas.openxmlformats.org/officeDocument/2006/relationships" id="259" r:id="Rc8365f3ea72444cd"/>
+    <p:sldId xmlns:r="http://schemas.openxmlformats.org/officeDocument/2006/relationships" id="260" r:id="R70689559036f49d6"/>
+    <p:sldId xmlns:r="http://schemas.openxmlformats.org/officeDocument/2006/relationships" id="261" r:id="Recc7c2506a5c414d"/>
+    <p:sldId xmlns:r="http://schemas.openxmlformats.org/officeDocument/2006/relationships" id="262" r:id="R4d3b832a6ec64465"/>
+    <p:sldId xmlns:r="http://schemas.openxmlformats.org/officeDocument/2006/relationships" id="263" r:id="R07a47966b79b4b4c"/>
+    <p:sldId xmlns:r="http://schemas.openxmlformats.org/officeDocument/2006/relationships" id="264" r:id="R0a0022bffd7642fc"/>
   </p:sldIdLst>
   <p:sldSz cx="12192000" cy="6858000"/>
   <p:notesSz cx="6858000" cy="9144000"/>
@@ -590,7 +590,7 @@
           <a:lstStyle xmlns:a="http://schemas.openxmlformats.org/drawingml/2006/main"/>
           <a:p xmlns:a="http://schemas.openxmlformats.org/drawingml/2006/main">
             <a:r>
-              <a:t>Источники: РОМИР, https://romir.ru/feed/roznitsa-trend-na-omnikanalnost ; НАФИ, N=1800, https://nafi.ru/polls/issledovanie-nafi-tolko-23-procenta-rossiyan-orientiruyutsya-na-bonusy-pri-vybore-magazina/ ; RuStore, исследовательский срез 06.09.2026, research/RUSTORE_REVIEWS.md. Ограничение RuStore: темы пересекаются, отзывы смещены к проблемам, точность тематических счётчиков около ±10%.</a:t>
+              <a:t>Источники: РОМИР, март 2025, https://romir.ru/feed/roznitsa-trend-na-omnikanalnost ; RuStore, 5 702 отзыва за 06.09.2024–06.09.2026, research/RUSTORE_REVIEWS.md ; BE FIT RCT, 200 взрослых из 94 семей, https://pmc.ncbi.nlm.nih.gov/articles/PMC5710273/ ; Inner Dragon RCT, N=500, https://pmc.ncbi.nlm.nih.gov/articles/PMC11561441/ . Ограничение: RCT относятся к другим индустриям и не доказывают влияние ростомера на покупки X5.</a:t>
             </a:r>
           </a:p>
         </p:txBody>
@@ -1078,7 +1078,7 @@
   </p:cSld>
   <p:clrMap bg1="lt1" tx1="dk1" bg2="lt2" tx2="dk2" accent1="accent1" accent2="accent2" accent3="accent3" accent4="accent4" accent5="accent5" accent6="accent6" hlink="hlink" folHlink="folHlink"/>
   <p:sldLayoutIdLst>
-    <p:sldLayoutId xmlns:r="http://schemas.openxmlformats.org/officeDocument/2006/relationships" id="2147483649" r:id="Re948fe90acd0408f"/>
+    <p:sldLayoutId xmlns:r="http://schemas.openxmlformats.org/officeDocument/2006/relationships" id="2147483649" r:id="R0ba22e80ba1347fe"/>
   </p:sldLayoutIdLst>
   <p:txStyles>
     <p:titleStyle>
@@ -1690,6 +1690,7 @@
           <a:lstStyle xmlns:a="http://schemas.openxmlformats.org/drawingml/2006/main"/>
           <a:p xmlns:a="http://schemas.openxmlformats.org/drawingml/2006/main">
             <a:pPr algn="l">
+              <a:buNone/>
               <a:defRPr sz="4350" b="1">
                 <a:solidFill>
                   <a:srgbClr val="171717"/>
@@ -1748,6 +1749,7 @@
           <a:lstStyle xmlns:a="http://schemas.openxmlformats.org/drawingml/2006/main"/>
           <a:p xmlns:a="http://schemas.openxmlformats.org/drawingml/2006/main">
             <a:pPr algn="l">
+              <a:buNone/>
               <a:defRPr sz="2550" b="0">
                 <a:solidFill>
                   <a:srgbClr val="171717"/>
@@ -1771,6 +1773,7 @@
           </a:p>
           <a:p xmlns:a="http://schemas.openxmlformats.org/drawingml/2006/main">
             <a:pPr algn="l">
+              <a:buNone/>
               <a:defRPr sz="2550" b="0">
                 <a:solidFill>
                   <a:srgbClr val="171717"/>
@@ -1829,6 +1832,7 @@
           <a:lstStyle xmlns:a="http://schemas.openxmlformats.org/drawingml/2006/main"/>
           <a:p xmlns:a="http://schemas.openxmlformats.org/drawingml/2006/main">
             <a:pPr algn="l">
+              <a:buNone/>
               <a:defRPr sz="1500" b="0">
                 <a:solidFill>
                   <a:srgbClr val="677078"/>
@@ -1918,6 +1922,7 @@
           <a:lstStyle xmlns:a="http://schemas.openxmlformats.org/drawingml/2006/main"/>
           <a:p xmlns:a="http://schemas.openxmlformats.org/drawingml/2006/main">
             <a:pPr algn="ctr">
+              <a:buNone/>
               <a:defRPr sz="3900" b="1">
                 <a:solidFill>
                   <a:srgbClr val="FFFFFF"/>
@@ -2007,6 +2012,7 @@
           <a:lstStyle xmlns:a="http://schemas.openxmlformats.org/drawingml/2006/main"/>
           <a:p xmlns:a="http://schemas.openxmlformats.org/drawingml/2006/main">
             <a:pPr algn="l">
+              <a:buNone/>
               <a:defRPr sz="900" b="1">
                 <a:solidFill>
                   <a:srgbClr val="FFFFFF"/>
@@ -2065,6 +2071,7 @@
           <a:lstStyle xmlns:a="http://schemas.openxmlformats.org/drawingml/2006/main"/>
           <a:p xmlns:a="http://schemas.openxmlformats.org/drawingml/2006/main">
             <a:pPr algn="l">
+              <a:buNone/>
               <a:defRPr sz="1200" b="1">
                 <a:solidFill>
                   <a:srgbClr val="171717"/>
@@ -2123,6 +2130,7 @@
           <a:lstStyle xmlns:a="http://schemas.openxmlformats.org/drawingml/2006/main"/>
           <a:p xmlns:a="http://schemas.openxmlformats.org/drawingml/2006/main">
             <a:pPr algn="r">
+              <a:buNone/>
               <a:defRPr sz="1350" b="1">
                 <a:solidFill>
                   <a:srgbClr val="00A651"/>
@@ -2210,6 +2218,7 @@
           <a:lstStyle xmlns:a="http://schemas.openxmlformats.org/drawingml/2006/main"/>
           <a:p xmlns:a="http://schemas.openxmlformats.org/drawingml/2006/main">
             <a:pPr algn="r">
+              <a:buNone/>
               <a:defRPr sz="6450" b="0">
                 <a:solidFill>
                   <a:srgbClr val="F1F2F5"/>
@@ -2268,6 +2277,7 @@
           <a:lstStyle xmlns:a="http://schemas.openxmlformats.org/drawingml/2006/main"/>
           <a:p xmlns:a="http://schemas.openxmlformats.org/drawingml/2006/main">
             <a:pPr algn="l">
+              <a:buNone/>
               <a:defRPr sz="2850" b="1">
                 <a:solidFill>
                   <a:srgbClr val="171717"/>
@@ -2326,6 +2336,7 @@
           <a:lstStyle xmlns:a="http://schemas.openxmlformats.org/drawingml/2006/main"/>
           <a:p xmlns:a="http://schemas.openxmlformats.org/drawingml/2006/main">
             <a:pPr algn="l">
+              <a:buNone/>
               <a:defRPr sz="1425" b="0">
                 <a:solidFill>
                   <a:srgbClr val="677078"/>
@@ -2415,6 +2426,7 @@
           <a:lstStyle xmlns:a="http://schemas.openxmlformats.org/drawingml/2006/main"/>
           <a:p xmlns:a="http://schemas.openxmlformats.org/drawingml/2006/main">
             <a:pPr algn="l">
+              <a:buNone/>
               <a:defRPr sz="900" b="1">
                 <a:solidFill>
                   <a:srgbClr val="FFFFFF"/>
@@ -2473,6 +2485,7 @@
           <a:lstStyle xmlns:a="http://schemas.openxmlformats.org/drawingml/2006/main"/>
           <a:p xmlns:a="http://schemas.openxmlformats.org/drawingml/2006/main">
             <a:pPr algn="l">
+              <a:buNone/>
               <a:defRPr sz="1200" b="1">
                 <a:solidFill>
                   <a:srgbClr val="171717"/>
@@ -2531,6 +2544,7 @@
           <a:lstStyle xmlns:a="http://schemas.openxmlformats.org/drawingml/2006/main"/>
           <a:p xmlns:a="http://schemas.openxmlformats.org/drawingml/2006/main">
             <a:pPr algn="r">
+              <a:buNone/>
               <a:defRPr sz="1350" b="1">
                 <a:solidFill>
                   <a:srgbClr val="00A651"/>
@@ -2589,6 +2603,7 @@
           <a:lstStyle xmlns:a="http://schemas.openxmlformats.org/drawingml/2006/main"/>
           <a:p xmlns:a="http://schemas.openxmlformats.org/drawingml/2006/main">
             <a:pPr algn="l">
+              <a:buNone/>
               <a:defRPr sz="1350" b="1">
                 <a:solidFill>
                   <a:srgbClr val="FF4F12"/>
@@ -2647,6 +2662,7 @@
           <a:lstStyle xmlns:a="http://schemas.openxmlformats.org/drawingml/2006/main"/>
           <a:p xmlns:a="http://schemas.openxmlformats.org/drawingml/2006/main">
             <a:pPr algn="l">
+              <a:buNone/>
               <a:defRPr sz="4050" b="1">
                 <a:solidFill>
                   <a:srgbClr val="171717"/>
@@ -2705,6 +2721,7 @@
           <a:lstStyle xmlns:a="http://schemas.openxmlformats.org/drawingml/2006/main"/>
           <a:p xmlns:a="http://schemas.openxmlformats.org/drawingml/2006/main">
             <a:pPr algn="l">
+              <a:buNone/>
               <a:defRPr sz="1725" b="0">
                 <a:solidFill>
                   <a:srgbClr val="677078"/>
@@ -2728,6 +2745,7 @@
           </a:p>
           <a:p xmlns:a="http://schemas.openxmlformats.org/drawingml/2006/main">
             <a:pPr algn="l">
+              <a:buNone/>
               <a:defRPr sz="1725" b="0">
                 <a:solidFill>
                   <a:srgbClr val="677078"/>
@@ -2817,6 +2835,7 @@
           <a:lstStyle xmlns:a="http://schemas.openxmlformats.org/drawingml/2006/main"/>
           <a:p xmlns:a="http://schemas.openxmlformats.org/drawingml/2006/main">
             <a:pPr algn="l">
+              <a:buNone/>
               <a:defRPr sz="1350" b="1">
                 <a:solidFill>
                   <a:srgbClr val="00A651"/>
@@ -2875,6 +2894,7 @@
           <a:lstStyle xmlns:a="http://schemas.openxmlformats.org/drawingml/2006/main"/>
           <a:p xmlns:a="http://schemas.openxmlformats.org/drawingml/2006/main">
             <a:pPr algn="l">
+              <a:buNone/>
               <a:defRPr sz="2625" b="1">
                 <a:solidFill>
                   <a:srgbClr val="171717"/>
@@ -2898,6 +2918,7 @@
           </a:p>
           <a:p xmlns:a="http://schemas.openxmlformats.org/drawingml/2006/main">
             <a:pPr algn="l">
+              <a:buNone/>
               <a:defRPr sz="2625" b="1">
                 <a:solidFill>
                   <a:srgbClr val="171717"/>
@@ -2956,6 +2977,7 @@
           <a:lstStyle xmlns:a="http://schemas.openxmlformats.org/drawingml/2006/main"/>
           <a:p xmlns:a="http://schemas.openxmlformats.org/drawingml/2006/main">
             <a:pPr algn="l">
+              <a:buNone/>
               <a:defRPr sz="1800" b="0">
                 <a:solidFill>
                   <a:srgbClr val="171717"/>
@@ -3047,6 +3069,7 @@
           <a:lstStyle xmlns:a="http://schemas.openxmlformats.org/drawingml/2006/main"/>
           <a:p xmlns:a="http://schemas.openxmlformats.org/drawingml/2006/main">
             <a:pPr algn="l">
+              <a:buNone/>
               <a:defRPr sz="1500" b="1">
                 <a:solidFill>
                   <a:srgbClr val="00A651"/>
@@ -3134,6 +3157,7 @@
           <a:lstStyle xmlns:a="http://schemas.openxmlformats.org/drawingml/2006/main"/>
           <a:p xmlns:a="http://schemas.openxmlformats.org/drawingml/2006/main">
             <a:pPr algn="r">
+              <a:buNone/>
               <a:defRPr sz="6450" b="0">
                 <a:solidFill>
                   <a:srgbClr val="F1F2F5"/>
@@ -3192,6 +3216,7 @@
           <a:lstStyle xmlns:a="http://schemas.openxmlformats.org/drawingml/2006/main"/>
           <a:p xmlns:a="http://schemas.openxmlformats.org/drawingml/2006/main">
             <a:pPr algn="l">
+              <a:buNone/>
               <a:defRPr sz="2850" b="1">
                 <a:solidFill>
                   <a:srgbClr val="171717"/>
@@ -3210,7 +3235,7 @@
                 <a:ea typeface="Arial"/>
                 <a:cs typeface="Arial"/>
               </a:rPr>
-              <a:t>Реальные сигналы и границы</a:t>
+              <a:t>Что известно и что проверяем</a:t>
             </a:r>
           </a:p>
         </p:txBody>
@@ -3250,6 +3275,7 @@
           <a:lstStyle xmlns:a="http://schemas.openxmlformats.org/drawingml/2006/main"/>
           <a:p xmlns:a="http://schemas.openxmlformats.org/drawingml/2006/main">
             <a:pPr algn="l">
+              <a:buNone/>
               <a:defRPr sz="1425" b="0">
                 <a:solidFill>
                   <a:srgbClr val="677078"/>
@@ -3268,7 +3294,7 @@
                 <a:ea typeface="Arial"/>
                 <a:cs typeface="Arial"/>
               </a:rPr>
-              <a:t>Проблема поддержана рынком и отзывами. Эффект ростомера требует пилота</a:t>
+              <a:t>Факты рынка отделены от переносимых экспериментов и гипотез решения</a:t>
             </a:r>
           </a:p>
         </p:txBody>
@@ -3339,6 +3365,7 @@
           <a:lstStyle xmlns:a="http://schemas.openxmlformats.org/drawingml/2006/main"/>
           <a:p xmlns:a="http://schemas.openxmlformats.org/drawingml/2006/main">
             <a:pPr algn="l">
+              <a:buNone/>
               <a:defRPr sz="900" b="1">
                 <a:solidFill>
                   <a:srgbClr val="FFFFFF"/>
@@ -3397,6 +3424,7 @@
           <a:lstStyle xmlns:a="http://schemas.openxmlformats.org/drawingml/2006/main"/>
           <a:p xmlns:a="http://schemas.openxmlformats.org/drawingml/2006/main">
             <a:pPr algn="l">
+              <a:buNone/>
               <a:defRPr sz="1200" b="1">
                 <a:solidFill>
                   <a:srgbClr val="171717"/>
@@ -3455,6 +3483,7 @@
           <a:lstStyle xmlns:a="http://schemas.openxmlformats.org/drawingml/2006/main"/>
           <a:p xmlns:a="http://schemas.openxmlformats.org/drawingml/2006/main">
             <a:pPr algn="r">
+              <a:buNone/>
               <a:defRPr sz="1350" b="1">
                 <a:solidFill>
                   <a:srgbClr val="00A651"/>
@@ -3513,6 +3542,7 @@
           <a:lstStyle xmlns:a="http://schemas.openxmlformats.org/drawingml/2006/main"/>
           <a:p xmlns:a="http://schemas.openxmlformats.org/drawingml/2006/main">
             <a:pPr algn="l">
+              <a:buNone/>
               <a:defRPr sz="4350" b="1">
                 <a:solidFill>
                   <a:srgbClr val="171717"/>
@@ -3571,6 +3601,7 @@
           <a:lstStyle xmlns:a="http://schemas.openxmlformats.org/drawingml/2006/main"/>
           <a:p xmlns:a="http://schemas.openxmlformats.org/drawingml/2006/main">
             <a:pPr algn="l">
+              <a:buNone/>
               <a:defRPr sz="1575" b="0">
                 <a:solidFill>
                   <a:srgbClr val="677078"/>
@@ -3629,6 +3660,7 @@
           <a:lstStyle xmlns:a="http://schemas.openxmlformats.org/drawingml/2006/main"/>
           <a:p xmlns:a="http://schemas.openxmlformats.org/drawingml/2006/main">
             <a:pPr algn="l">
+              <a:buNone/>
               <a:defRPr sz="1425" b="1">
                 <a:solidFill>
                   <a:srgbClr val="00A651"/>
@@ -3700,7 +3732,7 @@
         <p:spPr>
           <a:xfrm xmlns:a="http://schemas.openxmlformats.org/drawingml/2006/main">
             <a:off x="4267200" y="1714500"/>
-            <a:ext cx="1714500" cy="666750"/>
+            <a:ext cx="2857500" cy="666750"/>
           </a:xfrm>
           <a:prstGeom xmlns:a="http://schemas.openxmlformats.org/drawingml/2006/main" prst="rect">
             <a:avLst/>
@@ -3718,6 +3750,7 @@
           <a:lstStyle xmlns:a="http://schemas.openxmlformats.org/drawingml/2006/main"/>
           <a:p xmlns:a="http://schemas.openxmlformats.org/drawingml/2006/main">
             <a:pPr algn="l">
+              <a:buNone/>
               <a:defRPr sz="3900" b="1">
                 <a:solidFill>
                   <a:srgbClr val="171717"/>
@@ -3736,7 +3769,7 @@
                 <a:ea typeface="Arial"/>
                 <a:cs typeface="Arial"/>
               </a:rPr>
-              <a:t>&gt;75%</a:t>
+              <a:t>0,53 / 0,32</a:t>
             </a:r>
           </a:p>
         </p:txBody>
@@ -3776,6 +3809,7 @@
           <a:lstStyle xmlns:a="http://schemas.openxmlformats.org/drawingml/2006/main"/>
           <a:p xmlns:a="http://schemas.openxmlformats.org/drawingml/2006/main">
             <a:pPr algn="l">
+              <a:buNone/>
               <a:defRPr sz="1575" b="0">
                 <a:solidFill>
                   <a:srgbClr val="677078"/>
@@ -3794,7 +3828,31 @@
                 <a:ea typeface="Arial"/>
                 <a:cs typeface="Arial"/>
               </a:rPr>
-              <a:t>семей с детьми участвуют в программах лояльности</a:t>
+              <a:t>доля дней выполнения цели</a:t>
+            </a:r>
+          </a:p>
+          <a:p xmlns:a="http://schemas.openxmlformats.org/drawingml/2006/main">
+            <a:pPr algn="l">
+              <a:buNone/>
+              <a:defRPr sz="1575" b="0">
+                <a:solidFill>
+                  <a:srgbClr val="677078"/>
+                </a:solidFill>
+                <a:latin typeface="Arial"/>
+                <a:ea typeface="Arial"/>
+                <a:cs typeface="Arial"/>
+              </a:defRPr>
+            </a:pPr>
+            <a:r>
+              <a:rPr sz="1575" b="0">
+                <a:solidFill>
+                  <a:srgbClr val="677078"/>
+                </a:solidFill>
+                <a:latin typeface="Arial"/>
+                <a:ea typeface="Arial"/>
+                <a:cs typeface="Arial"/>
+              </a:rPr>
+              <a:t>BE FIT, 200 взрослых</a:t>
             </a:r>
           </a:p>
         </p:txBody>
@@ -3816,7 +3874,7 @@
         <p:spPr>
           <a:xfrm xmlns:a="http://schemas.openxmlformats.org/drawingml/2006/main">
             <a:off x="4267200" y="3200400"/>
-            <a:ext cx="2857500" cy="723900"/>
+            <a:ext cx="2857500" cy="1123950"/>
           </a:xfrm>
           <a:prstGeom xmlns:a="http://schemas.openxmlformats.org/drawingml/2006/main" prst="rect">
             <a:avLst/>
@@ -3834,6 +3892,7 @@
           <a:lstStyle xmlns:a="http://schemas.openxmlformats.org/drawingml/2006/main"/>
           <a:p xmlns:a="http://schemas.openxmlformats.org/drawingml/2006/main">
             <a:pPr algn="l">
+              <a:buNone/>
               <a:defRPr sz="1425" b="1">
                 <a:solidFill>
                   <a:srgbClr val="FF4F12"/>
@@ -3852,7 +3911,55 @@
                 <a:ea typeface="Arial"/>
                 <a:cs typeface="Arial"/>
               </a:rPr>
-              <a:t>Выгода решает: кешбэк 63%, бонусы 63%, скидки 59%</a:t>
+              <a:t>Inner Dragon, N=500</a:t>
+            </a:r>
+          </a:p>
+          <a:p xmlns:a="http://schemas.openxmlformats.org/drawingml/2006/main">
+            <a:pPr algn="l">
+              <a:buNone/>
+              <a:defRPr sz="1425" b="1">
+                <a:solidFill>
+                  <a:srgbClr val="FF4F12"/>
+                </a:solidFill>
+                <a:latin typeface="Arial"/>
+                <a:ea typeface="Arial"/>
+                <a:cs typeface="Arial"/>
+              </a:defRPr>
+            </a:pPr>
+            <a:r>
+              <a:rPr sz="1425" b="1">
+                <a:solidFill>
+                  <a:srgbClr val="FF4F12"/>
+                </a:solidFill>
+                <a:latin typeface="Arial"/>
+                <a:ea typeface="Arial"/>
+                <a:cs typeface="Arial"/>
+              </a:rPr>
+              <a:t>+20,2% дней использования</a:t>
+            </a:r>
+          </a:p>
+          <a:p xmlns:a="http://schemas.openxmlformats.org/drawingml/2006/main">
+            <a:pPr algn="l">
+              <a:buNone/>
+              <a:defRPr sz="1425" b="1">
+                <a:solidFill>
+                  <a:srgbClr val="FF4F12"/>
+                </a:solidFill>
+                <a:latin typeface="Arial"/>
+                <a:ea typeface="Arial"/>
+                <a:cs typeface="Arial"/>
+              </a:defRPr>
+            </a:pPr>
+            <a:r>
+              <a:rPr sz="1425" b="1">
+                <a:solidFill>
+                  <a:srgbClr val="FF4F12"/>
+                </a:solidFill>
+                <a:latin typeface="Arial"/>
+                <a:ea typeface="Arial"/>
+                <a:cs typeface="Arial"/>
+              </a:rPr>
+              <a:t>без эффекта на outcome</a:t>
             </a:r>
           </a:p>
         </p:txBody>
@@ -3923,6 +4030,7 @@
           <a:lstStyle xmlns:a="http://schemas.openxmlformats.org/drawingml/2006/main"/>
           <a:p xmlns:a="http://schemas.openxmlformats.org/drawingml/2006/main">
             <a:pPr algn="l">
+              <a:buNone/>
               <a:defRPr sz="3900" b="1">
                 <a:solidFill>
                   <a:srgbClr val="171717"/>
@@ -3941,7 +4049,7 @@
                 <a:ea typeface="Arial"/>
                 <a:cs typeface="Arial"/>
               </a:rPr>
-              <a:t>5 702</a:t>
+              <a:t>C &gt; B?</a:t>
             </a:r>
           </a:p>
         </p:txBody>
@@ -3963,7 +4071,7 @@
         <p:spPr>
           <a:xfrm xmlns:a="http://schemas.openxmlformats.org/drawingml/2006/main">
             <a:off x="7943850" y="2381250"/>
-            <a:ext cx="3048000" cy="514350"/>
+            <a:ext cx="3048000" cy="666750"/>
           </a:xfrm>
           <a:prstGeom xmlns:a="http://schemas.openxmlformats.org/drawingml/2006/main" prst="rect">
             <a:avLst/>
@@ -3981,6 +4089,7 @@
           <a:lstStyle xmlns:a="http://schemas.openxmlformats.org/drawingml/2006/main"/>
           <a:p xmlns:a="http://schemas.openxmlformats.org/drawingml/2006/main">
             <a:pPr algn="l">
+              <a:buNone/>
               <a:defRPr sz="1575" b="0">
                 <a:solidFill>
                   <a:srgbClr val="677078"/>
@@ -3999,7 +4108,31 @@
                 <a:ea typeface="Arial"/>
                 <a:cs typeface="Arial"/>
               </a:rPr>
-              <a:t>отзыва Пятёрочки за 24 месяца</a:t>
+              <a:t>ценность общего</a:t>
+            </a:r>
+          </a:p>
+          <a:p xmlns:a="http://schemas.openxmlformats.org/drawingml/2006/main">
+            <a:pPr algn="l">
+              <a:buNone/>
+              <a:defRPr sz="1575" b="0">
+                <a:solidFill>
+                  <a:srgbClr val="677078"/>
+                </a:solidFill>
+                <a:latin typeface="Arial"/>
+                <a:ea typeface="Arial"/>
+                <a:cs typeface="Arial"/>
+              </a:defRPr>
+            </a:pPr>
+            <a:r>
+              <a:rPr sz="1575" b="0">
+                <a:solidFill>
+                  <a:srgbClr val="677078"/>
+                </a:solidFill>
+                <a:latin typeface="Arial"/>
+                <a:ea typeface="Arial"/>
+                <a:cs typeface="Arial"/>
+              </a:rPr>
+              <a:t>результата семьи</a:t>
             </a:r>
           </a:p>
         </p:txBody>
@@ -4021,7 +4154,7 @@
         <p:spPr>
           <a:xfrm xmlns:a="http://schemas.openxmlformats.org/drawingml/2006/main">
             <a:off x="7943850" y="3086100"/>
-            <a:ext cx="3143250" cy="1428750"/>
+            <a:ext cx="3143250" cy="1238250"/>
           </a:xfrm>
           <a:prstGeom xmlns:a="http://schemas.openxmlformats.org/drawingml/2006/main" prst="rect">
             <a:avLst/>
@@ -4061,7 +4194,7 @@
                 <a:ea typeface="Arial"/>
                 <a:cs typeface="Arial"/>
               </a:rPr>
-              <a:t>518 упоминаний карты на кассе</a:t>
+              <a:t>D &gt; C? эффект ростомера</a:t>
             </a:r>
           </a:p>
           <a:p xmlns:a="http://schemas.openxmlformats.org/drawingml/2006/main">
@@ -4088,7 +4221,7 @@
                 <a:ea typeface="Arial"/>
                 <a:cs typeface="Arial"/>
               </a:rPr>
-              <a:t>106 просьб убрать игры или рекламу с главного</a:t>
+              <a:t>Прямого доказательства нет</a:t>
             </a:r>
           </a:p>
           <a:p xmlns:a="http://schemas.openxmlformats.org/drawingml/2006/main">
@@ -4115,7 +4248,7 @@
                 <a:ea typeface="Arial"/>
                 <a:cs typeface="Arial"/>
               </a:rPr>
-              <a:t>119 упоминаний отсутствия интернета</a:t>
+              <a:t>Проверяем реальным пилотом</a:t>
             </a:r>
           </a:p>
         </p:txBody>
@@ -4188,6 +4321,7 @@
           <a:lstStyle xmlns:a="http://schemas.openxmlformats.org/drawingml/2006/main"/>
           <a:p xmlns:a="http://schemas.openxmlformats.org/drawingml/2006/main">
             <a:pPr algn="ctr">
+              <a:buNone/>
               <a:defRPr sz="1650" b="1">
                 <a:solidFill>
                   <a:srgbClr val="FFFFFF"/>
@@ -4206,7 +4340,181 @@
                 <a:ea typeface="Arial"/>
                 <a:cs typeface="Arial"/>
               </a:rPr>
-              <a:t>Карта первой. Экономия по чеку. Ростомер после покупки</a:t>
+              <a:t>RuStore, 5 702: карта первой. Экономия по чеку. Ростомер после покупки</a:t>
+            </a:r>
+          </a:p>
+        </p:txBody>
+      </p:sp>
+      <p:sp>
+        <p:nvSpPr>
+          <p:cNvPr id="22" name="evidence-market-label">
+            <a:extLst xmlns:a="http://schemas.openxmlformats.org/drawingml/2006/main">
+              <a:ext uri="{FF2B5EF4-FFF2-40B4-BE49-F238E27FC236}">
+                <a16:creationId xmlns:a16="http://schemas.microsoft.com/office/drawing/2014/main" id="{A8530294-7C1D-4957-8C8F-DD7D2C26E6F4}"/>
+              </a:ext>
+            </a:extLst>
+          </p:cNvPr>
+          <p:cNvSpPr>
+            <a:spLocks xmlns:a="http://schemas.openxmlformats.org/drawingml/2006/main" noGrp="1"/>
+          </p:cNvSpPr>
+          <p:nvPr/>
+        </p:nvSpPr>
+        <p:spPr>
+          <a:xfrm xmlns:a="http://schemas.openxmlformats.org/drawingml/2006/main">
+            <a:off x="609600" y="1485900"/>
+            <a:ext cx="2952750" cy="228600"/>
+          </a:xfrm>
+          <a:prstGeom xmlns:a="http://schemas.openxmlformats.org/drawingml/2006/main" prst="rect">
+            <a:avLst/>
+          </a:prstGeom>
+          <a:noFill xmlns:a="http://schemas.openxmlformats.org/drawingml/2006/main"/>
+          <a:ln xmlns:a="http://schemas.openxmlformats.org/drawingml/2006/main" w="0">
+            <a:noFill/>
+          </a:ln>
+        </p:spPr>
+        <p:txBody>
+          <a:bodyPr xmlns:a="http://schemas.openxmlformats.org/drawingml/2006/main">
+            <a:noAutofit/>
+          </a:bodyPr>
+          <a:lstStyle xmlns:a="http://schemas.openxmlformats.org/drawingml/2006/main"/>
+          <a:p xmlns:a="http://schemas.openxmlformats.org/drawingml/2006/main">
+            <a:pPr>
+              <a:buNone/>
+              <a:defRPr sz="1050" b="1">
+                <a:solidFill>
+                  <a:srgbClr val="00A651"/>
+                </a:solidFill>
+                <a:latin typeface="Arial"/>
+                <a:ea typeface="Arial"/>
+                <a:cs typeface="Arial"/>
+              </a:defRPr>
+            </a:pPr>
+            <a:r>
+              <a:rPr sz="1050" b="1">
+                <a:solidFill>
+                  <a:srgbClr val="00A651"/>
+                </a:solidFill>
+                <a:latin typeface="Arial"/>
+                <a:ea typeface="Arial"/>
+                <a:cs typeface="Arial"/>
+              </a:rPr>
+              <a:t>РОССИЙСКИЙ РЫНОК</a:t>
+            </a:r>
+          </a:p>
+        </p:txBody>
+      </p:sp>
+      <p:sp>
+        <p:nvSpPr>
+          <p:cNvPr id="23" name="evidence-transfer-label">
+            <a:extLst xmlns:a="http://schemas.openxmlformats.org/drawingml/2006/main">
+              <a:ext uri="{FF2B5EF4-FFF2-40B4-BE49-F238E27FC236}">
+                <a16:creationId xmlns:a16="http://schemas.microsoft.com/office/drawing/2014/main" id="{922791E9-87C3-4092-9572-5B49E2C5ED29}"/>
+              </a:ext>
+            </a:extLst>
+          </p:cNvPr>
+          <p:cNvSpPr>
+            <a:spLocks xmlns:a="http://schemas.openxmlformats.org/drawingml/2006/main" noGrp="1"/>
+          </p:cNvSpPr>
+          <p:nvPr/>
+        </p:nvSpPr>
+        <p:spPr>
+          <a:xfrm xmlns:a="http://schemas.openxmlformats.org/drawingml/2006/main">
+            <a:off x="4267200" y="1485900"/>
+            <a:ext cx="2952750" cy="228600"/>
+          </a:xfrm>
+          <a:prstGeom xmlns:a="http://schemas.openxmlformats.org/drawingml/2006/main" prst="rect">
+            <a:avLst/>
+          </a:prstGeom>
+          <a:noFill xmlns:a="http://schemas.openxmlformats.org/drawingml/2006/main"/>
+          <a:ln xmlns:a="http://schemas.openxmlformats.org/drawingml/2006/main" w="0">
+            <a:noFill/>
+          </a:ln>
+        </p:spPr>
+        <p:txBody>
+          <a:bodyPr xmlns:a="http://schemas.openxmlformats.org/drawingml/2006/main">
+            <a:noAutofit/>
+          </a:bodyPr>
+          <a:lstStyle xmlns:a="http://schemas.openxmlformats.org/drawingml/2006/main"/>
+          <a:p xmlns:a="http://schemas.openxmlformats.org/drawingml/2006/main">
+            <a:pPr>
+              <a:buNone/>
+              <a:defRPr sz="1050" b="1">
+                <a:solidFill>
+                  <a:srgbClr val="FF4B18"/>
+                </a:solidFill>
+                <a:latin typeface="Arial"/>
+                <a:ea typeface="Arial"/>
+                <a:cs typeface="Arial"/>
+              </a:defRPr>
+            </a:pPr>
+            <a:r>
+              <a:rPr sz="1050" b="1">
+                <a:solidFill>
+                  <a:srgbClr val="FF4B18"/>
+                </a:solidFill>
+                <a:latin typeface="Arial"/>
+                <a:ea typeface="Arial"/>
+                <a:cs typeface="Arial"/>
+              </a:rPr>
+              <a:t>ПЕРЕНОСИМЫЕ RCT</a:t>
+            </a:r>
+          </a:p>
+        </p:txBody>
+      </p:sp>
+      <p:sp>
+        <p:nvSpPr>
+          <p:cNvPr id="24" name="evidence-hypothesis-label">
+            <a:extLst xmlns:a="http://schemas.openxmlformats.org/drawingml/2006/main">
+              <a:ext uri="{FF2B5EF4-FFF2-40B4-BE49-F238E27FC236}">
+                <a16:creationId xmlns:a16="http://schemas.microsoft.com/office/drawing/2014/main" id="{54F21A46-ABB7-4E90-BB8B-219E81B8FC56}"/>
+              </a:ext>
+            </a:extLst>
+          </p:cNvPr>
+          <p:cNvSpPr>
+            <a:spLocks xmlns:a="http://schemas.openxmlformats.org/drawingml/2006/main" noGrp="1"/>
+          </p:cNvSpPr>
+          <p:nvPr/>
+        </p:nvSpPr>
+        <p:spPr>
+          <a:xfrm xmlns:a="http://schemas.openxmlformats.org/drawingml/2006/main">
+            <a:off x="7943850" y="1485900"/>
+            <a:ext cx="2952750" cy="228600"/>
+          </a:xfrm>
+          <a:prstGeom xmlns:a="http://schemas.openxmlformats.org/drawingml/2006/main" prst="rect">
+            <a:avLst/>
+          </a:prstGeom>
+          <a:noFill xmlns:a="http://schemas.openxmlformats.org/drawingml/2006/main"/>
+          <a:ln xmlns:a="http://schemas.openxmlformats.org/drawingml/2006/main" w="0">
+            <a:noFill/>
+          </a:ln>
+        </p:spPr>
+        <p:txBody>
+          <a:bodyPr xmlns:a="http://schemas.openxmlformats.org/drawingml/2006/main">
+            <a:noAutofit/>
+          </a:bodyPr>
+          <a:lstStyle xmlns:a="http://schemas.openxmlformats.org/drawingml/2006/main"/>
+          <a:p xmlns:a="http://schemas.openxmlformats.org/drawingml/2006/main">
+            <a:pPr>
+              <a:buNone/>
+              <a:defRPr sz="1050" b="1">
+                <a:solidFill>
+                  <a:srgbClr val="1A1A1A"/>
+                </a:solidFill>
+                <a:latin typeface="Arial"/>
+                <a:ea typeface="Arial"/>
+                <a:cs typeface="Arial"/>
+              </a:defRPr>
+            </a:pPr>
+            <a:r>
+              <a:rPr sz="1050" b="1">
+                <a:solidFill>
+                  <a:srgbClr val="1A1A1A"/>
+                </a:solidFill>
+                <a:latin typeface="Arial"/>
+                <a:ea typeface="Arial"/>
+                <a:cs typeface="Arial"/>
+              </a:rPr>
+              <a:t>НЕПРОВЕРЕННЫЕ ГИПОТЕЗЫ</a:t>
             </a:r>
           </a:p>
         </p:txBody>
@@ -4275,6 +4583,7 @@
           <a:lstStyle xmlns:a="http://schemas.openxmlformats.org/drawingml/2006/main"/>
           <a:p xmlns:a="http://schemas.openxmlformats.org/drawingml/2006/main">
             <a:pPr algn="r">
+              <a:buNone/>
               <a:defRPr sz="6450" b="0">
                 <a:solidFill>
                   <a:srgbClr val="F1F2F5"/>
@@ -4333,6 +4642,7 @@
           <a:lstStyle xmlns:a="http://schemas.openxmlformats.org/drawingml/2006/main"/>
           <a:p xmlns:a="http://schemas.openxmlformats.org/drawingml/2006/main">
             <a:pPr algn="l">
+              <a:buNone/>
               <a:defRPr sz="2850" b="1">
                 <a:solidFill>
                   <a:srgbClr val="171717"/>
@@ -4391,6 +4701,7 @@
           <a:lstStyle xmlns:a="http://schemas.openxmlformats.org/drawingml/2006/main"/>
           <a:p xmlns:a="http://schemas.openxmlformats.org/drawingml/2006/main">
             <a:pPr algn="l">
+              <a:buNone/>
               <a:defRPr sz="1425" b="0">
                 <a:solidFill>
                   <a:srgbClr val="677078"/>
@@ -4480,6 +4791,7 @@
           <a:lstStyle xmlns:a="http://schemas.openxmlformats.org/drawingml/2006/main"/>
           <a:p xmlns:a="http://schemas.openxmlformats.org/drawingml/2006/main">
             <a:pPr algn="l">
+              <a:buNone/>
               <a:defRPr sz="900" b="1">
                 <a:solidFill>
                   <a:srgbClr val="FFFFFF"/>
@@ -4538,6 +4850,7 @@
           <a:lstStyle xmlns:a="http://schemas.openxmlformats.org/drawingml/2006/main"/>
           <a:p xmlns:a="http://schemas.openxmlformats.org/drawingml/2006/main">
             <a:pPr algn="l">
+              <a:buNone/>
               <a:defRPr sz="1200" b="1">
                 <a:solidFill>
                   <a:srgbClr val="171717"/>
@@ -4596,6 +4909,7 @@
           <a:lstStyle xmlns:a="http://schemas.openxmlformats.org/drawingml/2006/main"/>
           <a:p xmlns:a="http://schemas.openxmlformats.org/drawingml/2006/main">
             <a:pPr algn="r">
+              <a:buNone/>
               <a:defRPr sz="1350" b="1">
                 <a:solidFill>
                   <a:srgbClr val="00A651"/>
@@ -4621,14 +4935,14 @@
       </p:sp>
       <p:pic>
         <p:nvPicPr>
-          <p:cNvPr id="33" name=""/>
+          <p:cNvPr id="35" name=""/>
           <p:cNvPicPr>
             <a:picLocks xmlns:a="http://schemas.openxmlformats.org/drawingml/2006/main" noChangeAspect="1"/>
           </p:cNvPicPr>
           <p:nvPr/>
         </p:nvPicPr>
         <p:blipFill>
-          <a:blip xmlns:r="http://schemas.openxmlformats.org/officeDocument/2006/relationships" xmlns:a="http://schemas.openxmlformats.org/drawingml/2006/main" r:embed="Rbae6858d2dc64185"/>
+          <a:blip xmlns:r="http://schemas.openxmlformats.org/officeDocument/2006/relationships" xmlns:a="http://schemas.openxmlformats.org/drawingml/2006/main" r:embed="Rcc6bc5847b694aae"/>
           <a:stretch xmlns:a="http://schemas.openxmlformats.org/drawingml/2006/main"/>
         </p:blipFill>
         <p:spPr>
@@ -4676,6 +4990,7 @@
           <a:lstStyle xmlns:a="http://schemas.openxmlformats.org/drawingml/2006/main"/>
           <a:p xmlns:a="http://schemas.openxmlformats.org/drawingml/2006/main">
             <a:pPr algn="l">
+              <a:buNone/>
               <a:defRPr sz="1575" b="1">
                 <a:solidFill>
                   <a:srgbClr val="00A651"/>
@@ -4734,6 +5049,7 @@
           <a:lstStyle xmlns:a="http://schemas.openxmlformats.org/drawingml/2006/main"/>
           <a:p xmlns:a="http://schemas.openxmlformats.org/drawingml/2006/main">
             <a:pPr algn="l">
+              <a:buNone/>
               <a:defRPr sz="1875" b="1">
                 <a:solidFill>
                   <a:srgbClr val="171717"/>
@@ -4792,6 +5108,7 @@
           <a:lstStyle xmlns:a="http://schemas.openxmlformats.org/drawingml/2006/main"/>
           <a:p xmlns:a="http://schemas.openxmlformats.org/drawingml/2006/main">
             <a:pPr algn="l">
+              <a:buNone/>
               <a:defRPr sz="1425" b="0">
                 <a:solidFill>
                   <a:srgbClr val="677078"/>
@@ -4881,6 +5198,7 @@
           <a:lstStyle xmlns:a="http://schemas.openxmlformats.org/drawingml/2006/main"/>
           <a:p xmlns:a="http://schemas.openxmlformats.org/drawingml/2006/main">
             <a:pPr algn="l">
+              <a:buNone/>
               <a:defRPr sz="1575" b="1">
                 <a:solidFill>
                   <a:srgbClr val="00A651"/>
@@ -4939,6 +5257,7 @@
           <a:lstStyle xmlns:a="http://schemas.openxmlformats.org/drawingml/2006/main"/>
           <a:p xmlns:a="http://schemas.openxmlformats.org/drawingml/2006/main">
             <a:pPr algn="l">
+              <a:buNone/>
               <a:defRPr sz="1875" b="1">
                 <a:solidFill>
                   <a:srgbClr val="171717"/>
@@ -4997,6 +5316,7 @@
           <a:lstStyle xmlns:a="http://schemas.openxmlformats.org/drawingml/2006/main"/>
           <a:p xmlns:a="http://schemas.openxmlformats.org/drawingml/2006/main">
             <a:pPr algn="l">
+              <a:buNone/>
               <a:defRPr sz="1425" b="0">
                 <a:solidFill>
                   <a:srgbClr val="677078"/>
@@ -5086,6 +5406,7 @@
           <a:lstStyle xmlns:a="http://schemas.openxmlformats.org/drawingml/2006/main"/>
           <a:p xmlns:a="http://schemas.openxmlformats.org/drawingml/2006/main">
             <a:pPr algn="l">
+              <a:buNone/>
               <a:defRPr sz="1575" b="1">
                 <a:solidFill>
                   <a:srgbClr val="00A651"/>
@@ -5144,6 +5465,7 @@
           <a:lstStyle xmlns:a="http://schemas.openxmlformats.org/drawingml/2006/main"/>
           <a:p xmlns:a="http://schemas.openxmlformats.org/drawingml/2006/main">
             <a:pPr algn="l">
+              <a:buNone/>
               <a:defRPr sz="1875" b="1">
                 <a:solidFill>
                   <a:srgbClr val="171717"/>
@@ -5202,6 +5524,7 @@
           <a:lstStyle xmlns:a="http://schemas.openxmlformats.org/drawingml/2006/main"/>
           <a:p xmlns:a="http://schemas.openxmlformats.org/drawingml/2006/main">
             <a:pPr algn="l">
+              <a:buNone/>
               <a:defRPr sz="1425" b="0">
                 <a:solidFill>
                   <a:srgbClr val="677078"/>
@@ -5291,6 +5614,7 @@
           <a:lstStyle xmlns:a="http://schemas.openxmlformats.org/drawingml/2006/main"/>
           <a:p xmlns:a="http://schemas.openxmlformats.org/drawingml/2006/main">
             <a:pPr algn="l">
+              <a:buNone/>
               <a:defRPr sz="1575" b="1">
                 <a:solidFill>
                   <a:srgbClr val="FF4F12"/>
@@ -5349,6 +5673,7 @@
           <a:lstStyle xmlns:a="http://schemas.openxmlformats.org/drawingml/2006/main"/>
           <a:p xmlns:a="http://schemas.openxmlformats.org/drawingml/2006/main">
             <a:pPr algn="l">
+              <a:buNone/>
               <a:defRPr sz="1875" b="1">
                 <a:solidFill>
                   <a:srgbClr val="171717"/>
@@ -5407,6 +5732,7 @@
           <a:lstStyle xmlns:a="http://schemas.openxmlformats.org/drawingml/2006/main"/>
           <a:p xmlns:a="http://schemas.openxmlformats.org/drawingml/2006/main">
             <a:pPr algn="l">
+              <a:buNone/>
               <a:defRPr sz="1425" b="0">
                 <a:solidFill>
                   <a:srgbClr val="677078"/>
@@ -5498,6 +5824,7 @@
           <a:lstStyle xmlns:a="http://schemas.openxmlformats.org/drawingml/2006/main"/>
           <a:p xmlns:a="http://schemas.openxmlformats.org/drawingml/2006/main">
             <a:pPr algn="l">
+              <a:buNone/>
               <a:defRPr sz="1425" b="1">
                 <a:solidFill>
                   <a:srgbClr val="FF4F12"/>
@@ -5585,6 +5912,7 @@
           <a:lstStyle xmlns:a="http://schemas.openxmlformats.org/drawingml/2006/main"/>
           <a:p xmlns:a="http://schemas.openxmlformats.org/drawingml/2006/main">
             <a:pPr algn="r">
+              <a:buNone/>
               <a:defRPr sz="6450" b="0">
                 <a:solidFill>
                   <a:srgbClr val="F1F2F5"/>
@@ -5643,6 +5971,7 @@
           <a:lstStyle xmlns:a="http://schemas.openxmlformats.org/drawingml/2006/main"/>
           <a:p xmlns:a="http://schemas.openxmlformats.org/drawingml/2006/main">
             <a:pPr algn="l">
+              <a:buNone/>
               <a:defRPr sz="2850" b="1">
                 <a:solidFill>
                   <a:srgbClr val="171717"/>
@@ -5701,6 +6030,7 @@
           <a:lstStyle xmlns:a="http://schemas.openxmlformats.org/drawingml/2006/main"/>
           <a:p xmlns:a="http://schemas.openxmlformats.org/drawingml/2006/main">
             <a:pPr algn="l">
+              <a:buNone/>
               <a:defRPr sz="1425" b="0">
                 <a:solidFill>
                   <a:srgbClr val="677078"/>
@@ -5790,6 +6120,7 @@
           <a:lstStyle xmlns:a="http://schemas.openxmlformats.org/drawingml/2006/main"/>
           <a:p xmlns:a="http://schemas.openxmlformats.org/drawingml/2006/main">
             <a:pPr algn="l">
+              <a:buNone/>
               <a:defRPr sz="900" b="1">
                 <a:solidFill>
                   <a:srgbClr val="FFFFFF"/>
@@ -5848,6 +6179,7 @@
           <a:lstStyle xmlns:a="http://schemas.openxmlformats.org/drawingml/2006/main"/>
           <a:p xmlns:a="http://schemas.openxmlformats.org/drawingml/2006/main">
             <a:pPr algn="l">
+              <a:buNone/>
               <a:defRPr sz="1200" b="1">
                 <a:solidFill>
                   <a:srgbClr val="171717"/>
@@ -5906,6 +6238,7 @@
           <a:lstStyle xmlns:a="http://schemas.openxmlformats.org/drawingml/2006/main"/>
           <a:p xmlns:a="http://schemas.openxmlformats.org/drawingml/2006/main">
             <a:pPr algn="r">
+              <a:buNone/>
               <a:defRPr sz="1350" b="1">
                 <a:solidFill>
                   <a:srgbClr val="00A651"/>
@@ -5964,6 +6297,7 @@
           <a:lstStyle xmlns:a="http://schemas.openxmlformats.org/drawingml/2006/main"/>
           <a:p xmlns:a="http://schemas.openxmlformats.org/drawingml/2006/main">
             <a:pPr algn="l">
+              <a:buNone/>
               <a:defRPr sz="1275" b="1">
                 <a:solidFill>
                   <a:srgbClr val="00A651"/>
@@ -6022,6 +6356,7 @@
           <a:lstStyle xmlns:a="http://schemas.openxmlformats.org/drawingml/2006/main"/>
           <a:p xmlns:a="http://schemas.openxmlformats.org/drawingml/2006/main">
             <a:pPr algn="l">
+              <a:buNone/>
               <a:defRPr sz="2250" b="1">
                 <a:solidFill>
                   <a:srgbClr val="171717"/>
@@ -6227,6 +6562,7 @@
           <a:lstStyle xmlns:a="http://schemas.openxmlformats.org/drawingml/2006/main"/>
           <a:p xmlns:a="http://schemas.openxmlformats.org/drawingml/2006/main">
             <a:pPr algn="l">
+              <a:buNone/>
               <a:defRPr sz="1275" b="1">
                 <a:solidFill>
                   <a:srgbClr val="FF4F12"/>
@@ -6285,6 +6621,7 @@
           <a:lstStyle xmlns:a="http://schemas.openxmlformats.org/drawingml/2006/main"/>
           <a:p xmlns:a="http://schemas.openxmlformats.org/drawingml/2006/main">
             <a:pPr algn="l">
+              <a:buNone/>
               <a:defRPr sz="2250" b="1">
                 <a:solidFill>
                   <a:srgbClr val="171717"/>
@@ -6490,6 +6827,7 @@
           <a:lstStyle xmlns:a="http://schemas.openxmlformats.org/drawingml/2006/main"/>
           <a:p xmlns:a="http://schemas.openxmlformats.org/drawingml/2006/main">
             <a:pPr algn="l">
+              <a:buNone/>
               <a:defRPr sz="1275" b="1">
                 <a:solidFill>
                   <a:srgbClr val="171717"/>
@@ -6548,6 +6886,7 @@
           <a:lstStyle xmlns:a="http://schemas.openxmlformats.org/drawingml/2006/main"/>
           <a:p xmlns:a="http://schemas.openxmlformats.org/drawingml/2006/main">
             <a:pPr algn="l">
+              <a:buNone/>
               <a:defRPr sz="2250" b="1">
                 <a:solidFill>
                   <a:srgbClr val="171717"/>
@@ -6786,6 +7125,7 @@
           <a:lstStyle xmlns:a="http://schemas.openxmlformats.org/drawingml/2006/main"/>
           <a:p xmlns:a="http://schemas.openxmlformats.org/drawingml/2006/main">
             <a:pPr algn="ctr">
+              <a:buNone/>
               <a:defRPr sz="1500" b="1">
                 <a:solidFill>
                   <a:srgbClr val="FFFFFF"/>
@@ -6873,6 +7213,7 @@
           <a:lstStyle xmlns:a="http://schemas.openxmlformats.org/drawingml/2006/main"/>
           <a:p xmlns:a="http://schemas.openxmlformats.org/drawingml/2006/main">
             <a:pPr algn="r">
+              <a:buNone/>
               <a:defRPr sz="6450" b="0">
                 <a:solidFill>
                   <a:srgbClr val="F1F2F5"/>
@@ -6931,6 +7272,7 @@
           <a:lstStyle xmlns:a="http://schemas.openxmlformats.org/drawingml/2006/main"/>
           <a:p xmlns:a="http://schemas.openxmlformats.org/drawingml/2006/main">
             <a:pPr algn="l">
+              <a:buNone/>
               <a:defRPr sz="2850" b="1">
                 <a:solidFill>
                   <a:srgbClr val="171717"/>
@@ -6989,6 +7331,7 @@
           <a:lstStyle xmlns:a="http://schemas.openxmlformats.org/drawingml/2006/main"/>
           <a:p xmlns:a="http://schemas.openxmlformats.org/drawingml/2006/main">
             <a:pPr algn="l">
+              <a:buNone/>
               <a:defRPr sz="1425" b="0">
                 <a:solidFill>
                   <a:srgbClr val="677078"/>
@@ -7078,6 +7421,7 @@
           <a:lstStyle xmlns:a="http://schemas.openxmlformats.org/drawingml/2006/main"/>
           <a:p xmlns:a="http://schemas.openxmlformats.org/drawingml/2006/main">
             <a:pPr algn="l">
+              <a:buNone/>
               <a:defRPr sz="900" b="1">
                 <a:solidFill>
                   <a:srgbClr val="FFFFFF"/>
@@ -7136,6 +7480,7 @@
           <a:lstStyle xmlns:a="http://schemas.openxmlformats.org/drawingml/2006/main"/>
           <a:p xmlns:a="http://schemas.openxmlformats.org/drawingml/2006/main">
             <a:pPr algn="l">
+              <a:buNone/>
               <a:defRPr sz="1200" b="1">
                 <a:solidFill>
                   <a:srgbClr val="171717"/>
@@ -7194,6 +7539,7 @@
           <a:lstStyle xmlns:a="http://schemas.openxmlformats.org/drawingml/2006/main"/>
           <a:p xmlns:a="http://schemas.openxmlformats.org/drawingml/2006/main">
             <a:pPr algn="r">
+              <a:buNone/>
               <a:defRPr sz="1350" b="1">
                 <a:solidFill>
                   <a:srgbClr val="00A651"/>
@@ -7252,6 +7598,7 @@
           <a:lstStyle xmlns:a="http://schemas.openxmlformats.org/drawingml/2006/main"/>
           <a:p xmlns:a="http://schemas.openxmlformats.org/drawingml/2006/main">
             <a:pPr algn="l">
+              <a:buNone/>
               <a:defRPr sz="4050" b="1">
                 <a:solidFill>
                   <a:srgbClr val="171717"/>
@@ -7291,8 +7638,8 @@
         </p:nvSpPr>
         <p:spPr>
           <a:xfrm xmlns:a="http://schemas.openxmlformats.org/drawingml/2006/main">
-            <a:off x="619125" y="2438400"/>
-            <a:ext cx="2857500" cy="400050"/>
+            <a:off x="619125" y="2400300"/>
+            <a:ext cx="2857500" cy="552450"/>
           </a:xfrm>
           <a:prstGeom xmlns:a="http://schemas.openxmlformats.org/drawingml/2006/main" prst="rect">
             <a:avLst/>
@@ -7310,6 +7657,7 @@
           <a:lstStyle xmlns:a="http://schemas.openxmlformats.org/drawingml/2006/main"/>
           <a:p xmlns:a="http://schemas.openxmlformats.org/drawingml/2006/main">
             <a:pPr algn="l">
+              <a:buNone/>
               <a:defRPr sz="1500" b="0">
                 <a:solidFill>
                   <a:srgbClr val="677078"/>
@@ -7328,7 +7676,31 @@
                 <a:ea typeface="Arial"/>
                 <a:cs typeface="Arial"/>
               </a:rPr>
-              <a:t>синтетических семей</a:t>
+              <a:t>профилей всех сегментов</a:t>
+            </a:r>
+          </a:p>
+          <a:p xmlns:a="http://schemas.openxmlformats.org/drawingml/2006/main">
+            <a:pPr algn="l">
+              <a:buNone/>
+              <a:defRPr sz="1500" b="0">
+                <a:solidFill>
+                  <a:srgbClr val="677078"/>
+                </a:solidFill>
+                <a:latin typeface="Arial"/>
+                <a:ea typeface="Arial"/>
+                <a:cs typeface="Arial"/>
+              </a:defRPr>
+            </a:pPr>
+            <a:r>
+              <a:rPr sz="1500" b="0">
+                <a:solidFill>
+                  <a:srgbClr val="677078"/>
+                </a:solidFill>
+                <a:latin typeface="Arial"/>
+                <a:ea typeface="Arial"/>
+                <a:cs typeface="Arial"/>
+              </a:rPr>
+              <a:t>≈510 целевой профиль</a:t>
             </a:r>
           </a:p>
         </p:txBody>
@@ -7399,6 +7771,7 @@
           <a:lstStyle xmlns:a="http://schemas.openxmlformats.org/drawingml/2006/main"/>
           <a:p xmlns:a="http://schemas.openxmlformats.org/drawingml/2006/main">
             <a:pPr algn="l">
+              <a:buNone/>
               <a:defRPr sz="4050" b="1">
                 <a:solidFill>
                   <a:srgbClr val="171717"/>
@@ -7457,6 +7830,7 @@
           <a:lstStyle xmlns:a="http://schemas.openxmlformats.org/drawingml/2006/main"/>
           <a:p xmlns:a="http://schemas.openxmlformats.org/drawingml/2006/main">
             <a:pPr algn="l">
+              <a:buNone/>
               <a:defRPr sz="1500" b="0">
                 <a:solidFill>
                   <a:srgbClr val="677078"/>
@@ -7546,6 +7920,7 @@
           <a:lstStyle xmlns:a="http://schemas.openxmlformats.org/drawingml/2006/main"/>
           <a:p xmlns:a="http://schemas.openxmlformats.org/drawingml/2006/main">
             <a:pPr algn="l">
+              <a:buNone/>
               <a:defRPr sz="4050" b="1">
                 <a:solidFill>
                   <a:srgbClr val="171717"/>
@@ -7604,6 +7979,7 @@
           <a:lstStyle xmlns:a="http://schemas.openxmlformats.org/drawingml/2006/main"/>
           <a:p xmlns:a="http://schemas.openxmlformats.org/drawingml/2006/main">
             <a:pPr algn="l">
+              <a:buNone/>
               <a:defRPr sz="1500" b="0">
                 <a:solidFill>
                   <a:srgbClr val="677078"/>
@@ -7693,6 +8069,7 @@
           <a:lstStyle xmlns:a="http://schemas.openxmlformats.org/drawingml/2006/main"/>
           <a:p xmlns:a="http://schemas.openxmlformats.org/drawingml/2006/main">
             <a:pPr algn="l">
+              <a:buNone/>
               <a:defRPr sz="4050" b="1">
                 <a:solidFill>
                   <a:srgbClr val="00A651"/>
@@ -7751,6 +8128,7 @@
           <a:lstStyle xmlns:a="http://schemas.openxmlformats.org/drawingml/2006/main"/>
           <a:p xmlns:a="http://schemas.openxmlformats.org/drawingml/2006/main">
             <a:pPr algn="l">
+              <a:buNone/>
               <a:defRPr sz="1650" b="0">
                 <a:solidFill>
                   <a:srgbClr val="171717"/>
@@ -7774,6 +8152,7 @@
           </a:p>
           <a:p xmlns:a="http://schemas.openxmlformats.org/drawingml/2006/main">
             <a:pPr algn="l">
+              <a:buNone/>
               <a:defRPr sz="1650" b="0">
                 <a:solidFill>
                   <a:srgbClr val="171717"/>
@@ -7832,6 +8211,7 @@
           <a:lstStyle xmlns:a="http://schemas.openxmlformats.org/drawingml/2006/main"/>
           <a:p xmlns:a="http://schemas.openxmlformats.org/drawingml/2006/main">
             <a:pPr algn="l">
+              <a:buNone/>
               <a:defRPr sz="4050" b="1">
                 <a:solidFill>
                   <a:srgbClr val="00A651"/>
@@ -7890,6 +8270,7 @@
           <a:lstStyle xmlns:a="http://schemas.openxmlformats.org/drawingml/2006/main"/>
           <a:p xmlns:a="http://schemas.openxmlformats.org/drawingml/2006/main">
             <a:pPr algn="l">
+              <a:buNone/>
               <a:defRPr sz="1650" b="0">
                 <a:solidFill>
                   <a:srgbClr val="171717"/>
@@ -7913,6 +8294,7 @@
           </a:p>
           <a:p xmlns:a="http://schemas.openxmlformats.org/drawingml/2006/main">
             <a:pPr algn="l">
+              <a:buNone/>
               <a:defRPr sz="1650" b="0">
                 <a:solidFill>
                   <a:srgbClr val="171717"/>
@@ -8004,6 +8386,7 @@
           <a:lstStyle xmlns:a="http://schemas.openxmlformats.org/drawingml/2006/main"/>
           <a:p xmlns:a="http://schemas.openxmlformats.org/drawingml/2006/main">
             <a:pPr algn="ctr">
+              <a:buNone/>
               <a:defRPr sz="1650" b="1">
                 <a:solidFill>
                   <a:srgbClr val="00A651"/>
@@ -8027,6 +8410,7 @@
           </a:p>
           <a:p xmlns:a="http://schemas.openxmlformats.org/drawingml/2006/main">
             <a:pPr algn="ctr">
+              <a:buNone/>
               <a:defRPr sz="1650" b="1">
                 <a:solidFill>
                   <a:srgbClr val="00A651"/>
@@ -8118,6 +8502,7 @@
           <a:lstStyle xmlns:a="http://schemas.openxmlformats.org/drawingml/2006/main"/>
           <a:p xmlns:a="http://schemas.openxmlformats.org/drawingml/2006/main">
             <a:pPr algn="ctr">
+              <a:buNone/>
               <a:defRPr sz="1650" b="1">
                 <a:solidFill>
                   <a:srgbClr val="FF4F12"/>
@@ -8141,6 +8526,7 @@
           </a:p>
           <a:p xmlns:a="http://schemas.openxmlformats.org/drawingml/2006/main">
             <a:pPr algn="ctr">
+              <a:buNone/>
               <a:defRPr sz="1650" b="1">
                 <a:solidFill>
                   <a:srgbClr val="FF4F12"/>
@@ -8228,6 +8614,7 @@
           <a:lstStyle xmlns:a="http://schemas.openxmlformats.org/drawingml/2006/main"/>
           <a:p xmlns:a="http://schemas.openxmlformats.org/drawingml/2006/main">
             <a:pPr algn="r">
+              <a:buNone/>
               <a:defRPr sz="6450" b="0">
                 <a:solidFill>
                   <a:srgbClr val="F1F2F5"/>
@@ -8286,6 +8673,7 @@
           <a:lstStyle xmlns:a="http://schemas.openxmlformats.org/drawingml/2006/main"/>
           <a:p xmlns:a="http://schemas.openxmlformats.org/drawingml/2006/main">
             <a:pPr algn="l">
+              <a:buNone/>
               <a:defRPr sz="2850" b="1">
                 <a:solidFill>
                   <a:srgbClr val="171717"/>
@@ -8344,6 +8732,7 @@
           <a:lstStyle xmlns:a="http://schemas.openxmlformats.org/drawingml/2006/main"/>
           <a:p xmlns:a="http://schemas.openxmlformats.org/drawingml/2006/main">
             <a:pPr algn="l">
+              <a:buNone/>
               <a:defRPr sz="1425" b="0">
                 <a:solidFill>
                   <a:srgbClr val="677078"/>
@@ -8433,6 +8822,7 @@
           <a:lstStyle xmlns:a="http://schemas.openxmlformats.org/drawingml/2006/main"/>
           <a:p xmlns:a="http://schemas.openxmlformats.org/drawingml/2006/main">
             <a:pPr algn="l">
+              <a:buNone/>
               <a:defRPr sz="900" b="1">
                 <a:solidFill>
                   <a:srgbClr val="FFFFFF"/>
@@ -8491,6 +8881,7 @@
           <a:lstStyle xmlns:a="http://schemas.openxmlformats.org/drawingml/2006/main"/>
           <a:p xmlns:a="http://schemas.openxmlformats.org/drawingml/2006/main">
             <a:pPr algn="l">
+              <a:buNone/>
               <a:defRPr sz="1200" b="1">
                 <a:solidFill>
                   <a:srgbClr val="171717"/>
@@ -8549,6 +8940,7 @@
           <a:lstStyle xmlns:a="http://schemas.openxmlformats.org/drawingml/2006/main"/>
           <a:p xmlns:a="http://schemas.openxmlformats.org/drawingml/2006/main">
             <a:pPr algn="r">
+              <a:buNone/>
               <a:defRPr sz="1350" b="1">
                 <a:solidFill>
                   <a:srgbClr val="00A651"/>
@@ -8640,6 +9032,7 @@
           <a:lstStyle xmlns:a="http://schemas.openxmlformats.org/drawingml/2006/main"/>
           <a:p xmlns:a="http://schemas.openxmlformats.org/drawingml/2006/main">
             <a:pPr algn="l">
+              <a:buNone/>
               <a:defRPr sz="3000" b="1">
                 <a:solidFill>
                   <a:srgbClr val="00A651"/>
@@ -8698,6 +9091,7 @@
           <a:lstStyle xmlns:a="http://schemas.openxmlformats.org/drawingml/2006/main"/>
           <a:p xmlns:a="http://schemas.openxmlformats.org/drawingml/2006/main">
             <a:pPr algn="l">
+              <a:buNone/>
               <a:defRPr sz="1800" b="1">
                 <a:solidFill>
                   <a:srgbClr val="171717"/>
@@ -8756,6 +9150,7 @@
           <a:lstStyle xmlns:a="http://schemas.openxmlformats.org/drawingml/2006/main"/>
           <a:p xmlns:a="http://schemas.openxmlformats.org/drawingml/2006/main">
             <a:pPr algn="l">
+              <a:buNone/>
               <a:defRPr sz="1425" b="0">
                 <a:solidFill>
                   <a:srgbClr val="677078"/>
@@ -8847,6 +9242,7 @@
           <a:lstStyle xmlns:a="http://schemas.openxmlformats.org/drawingml/2006/main"/>
           <a:p xmlns:a="http://schemas.openxmlformats.org/drawingml/2006/main">
             <a:pPr algn="l">
+              <a:buNone/>
               <a:defRPr sz="3000" b="1">
                 <a:solidFill>
                   <a:srgbClr val="00A651"/>
@@ -8905,6 +9301,7 @@
           <a:lstStyle xmlns:a="http://schemas.openxmlformats.org/drawingml/2006/main"/>
           <a:p xmlns:a="http://schemas.openxmlformats.org/drawingml/2006/main">
             <a:pPr algn="l">
+              <a:buNone/>
               <a:defRPr sz="1800" b="1">
                 <a:solidFill>
                   <a:srgbClr val="171717"/>
@@ -8963,6 +9360,7 @@
           <a:lstStyle xmlns:a="http://schemas.openxmlformats.org/drawingml/2006/main"/>
           <a:p xmlns:a="http://schemas.openxmlformats.org/drawingml/2006/main">
             <a:pPr algn="l">
+              <a:buNone/>
               <a:defRPr sz="1425" b="0">
                 <a:solidFill>
                   <a:srgbClr val="677078"/>
@@ -9054,6 +9452,7 @@
           <a:lstStyle xmlns:a="http://schemas.openxmlformats.org/drawingml/2006/main"/>
           <a:p xmlns:a="http://schemas.openxmlformats.org/drawingml/2006/main">
             <a:pPr algn="l">
+              <a:buNone/>
               <a:defRPr sz="3000" b="1">
                 <a:solidFill>
                   <a:srgbClr val="00A651"/>
@@ -9112,6 +9511,7 @@
           <a:lstStyle xmlns:a="http://schemas.openxmlformats.org/drawingml/2006/main"/>
           <a:p xmlns:a="http://schemas.openxmlformats.org/drawingml/2006/main">
             <a:pPr algn="l">
+              <a:buNone/>
               <a:defRPr sz="1800" b="1">
                 <a:solidFill>
                   <a:srgbClr val="171717"/>
@@ -9170,6 +9570,7 @@
           <a:lstStyle xmlns:a="http://schemas.openxmlformats.org/drawingml/2006/main"/>
           <a:p xmlns:a="http://schemas.openxmlformats.org/drawingml/2006/main">
             <a:pPr algn="l">
+              <a:buNone/>
               <a:defRPr sz="1425" b="0">
                 <a:solidFill>
                   <a:srgbClr val="677078"/>
@@ -9261,6 +9662,7 @@
           <a:lstStyle xmlns:a="http://schemas.openxmlformats.org/drawingml/2006/main"/>
           <a:p xmlns:a="http://schemas.openxmlformats.org/drawingml/2006/main">
             <a:pPr algn="l">
+              <a:buNone/>
               <a:defRPr sz="3000" b="1">
                 <a:solidFill>
                   <a:srgbClr val="FF4F12"/>
@@ -9319,6 +9721,7 @@
           <a:lstStyle xmlns:a="http://schemas.openxmlformats.org/drawingml/2006/main"/>
           <a:p xmlns:a="http://schemas.openxmlformats.org/drawingml/2006/main">
             <a:pPr algn="l">
+              <a:buNone/>
               <a:defRPr sz="1800" b="1">
                 <a:solidFill>
                   <a:srgbClr val="FFFFFF"/>
@@ -9377,6 +9780,7 @@
           <a:lstStyle xmlns:a="http://schemas.openxmlformats.org/drawingml/2006/main"/>
           <a:p xmlns:a="http://schemas.openxmlformats.org/drawingml/2006/main">
             <a:pPr algn="l">
+              <a:buNone/>
               <a:defRPr sz="1425" b="0">
                 <a:solidFill>
                   <a:srgbClr val="DADDE2"/>
@@ -9435,6 +9839,7 @@
           <a:lstStyle xmlns:a="http://schemas.openxmlformats.org/drawingml/2006/main"/>
           <a:p xmlns:a="http://schemas.openxmlformats.org/drawingml/2006/main">
             <a:pPr algn="ctr">
+              <a:buNone/>
               <a:defRPr sz="1875" b="1">
                 <a:solidFill>
                   <a:srgbClr val="00A651"/>
@@ -9493,6 +9898,7 @@
           <a:lstStyle xmlns:a="http://schemas.openxmlformats.org/drawingml/2006/main"/>
           <a:p xmlns:a="http://schemas.openxmlformats.org/drawingml/2006/main">
             <a:pPr algn="ctr">
+              <a:buNone/>
               <a:defRPr sz="1350" b="0">
                 <a:solidFill>
                   <a:srgbClr val="677078"/>
@@ -9551,6 +9957,7 @@
           <a:lstStyle xmlns:a="http://schemas.openxmlformats.org/drawingml/2006/main"/>
           <a:p xmlns:a="http://schemas.openxmlformats.org/drawingml/2006/main">
             <a:pPr algn="ctr">
+              <a:buNone/>
               <a:defRPr sz="1875" b="1">
                 <a:solidFill>
                   <a:srgbClr val="00A651"/>
@@ -9609,6 +10016,7 @@
           <a:lstStyle xmlns:a="http://schemas.openxmlformats.org/drawingml/2006/main"/>
           <a:p xmlns:a="http://schemas.openxmlformats.org/drawingml/2006/main">
             <a:pPr algn="ctr">
+              <a:buNone/>
               <a:defRPr sz="1350" b="0">
                 <a:solidFill>
                   <a:srgbClr val="677078"/>
@@ -9667,6 +10075,7 @@
           <a:lstStyle xmlns:a="http://schemas.openxmlformats.org/drawingml/2006/main"/>
           <a:p xmlns:a="http://schemas.openxmlformats.org/drawingml/2006/main">
             <a:pPr algn="ctr">
+              <a:buNone/>
               <a:defRPr sz="1875" b="1">
                 <a:solidFill>
                   <a:srgbClr val="FF4F12"/>
@@ -9725,6 +10134,7 @@
           <a:lstStyle xmlns:a="http://schemas.openxmlformats.org/drawingml/2006/main"/>
           <a:p xmlns:a="http://schemas.openxmlformats.org/drawingml/2006/main">
             <a:pPr algn="ctr">
+              <a:buNone/>
               <a:defRPr sz="1350" b="0">
                 <a:solidFill>
                   <a:srgbClr val="677078"/>
@@ -9816,6 +10226,7 @@
           <a:lstStyle xmlns:a="http://schemas.openxmlformats.org/drawingml/2006/main"/>
           <a:p xmlns:a="http://schemas.openxmlformats.org/drawingml/2006/main">
             <a:pPr algn="l">
+              <a:buNone/>
               <a:defRPr sz="1200" b="1">
                 <a:solidFill>
                   <a:srgbClr val="00A651"/>
@@ -9874,6 +10285,7 @@
           <a:lstStyle xmlns:a="http://schemas.openxmlformats.org/drawingml/2006/main"/>
           <a:p xmlns:a="http://schemas.openxmlformats.org/drawingml/2006/main">
             <a:pPr algn="l">
+              <a:buNone/>
               <a:defRPr sz="1575" b="1">
                 <a:solidFill>
                   <a:srgbClr val="171717"/>
@@ -9897,6 +10309,7 @@
           </a:p>
           <a:p xmlns:a="http://schemas.openxmlformats.org/drawingml/2006/main">
             <a:pPr algn="l">
+              <a:buNone/>
               <a:defRPr sz="1575" b="1">
                 <a:solidFill>
                   <a:srgbClr val="171717"/>
@@ -9955,6 +10368,7 @@
           <a:lstStyle xmlns:a="http://schemas.openxmlformats.org/drawingml/2006/main"/>
           <a:p xmlns:a="http://schemas.openxmlformats.org/drawingml/2006/main">
             <a:pPr algn="ctr">
+              <a:buNone/>
               <a:defRPr sz="1425" b="0">
                 <a:solidFill>
                   <a:srgbClr val="677078"/>
@@ -10042,6 +10456,7 @@
           <a:lstStyle xmlns:a="http://schemas.openxmlformats.org/drawingml/2006/main"/>
           <a:p xmlns:a="http://schemas.openxmlformats.org/drawingml/2006/main">
             <a:pPr algn="r">
+              <a:buNone/>
               <a:defRPr sz="6450" b="0">
                 <a:solidFill>
                   <a:srgbClr val="F1F2F5"/>
@@ -10100,6 +10515,7 @@
           <a:lstStyle xmlns:a="http://schemas.openxmlformats.org/drawingml/2006/main"/>
           <a:p xmlns:a="http://schemas.openxmlformats.org/drawingml/2006/main">
             <a:pPr algn="l">
+              <a:buNone/>
               <a:defRPr sz="2850" b="1">
                 <a:solidFill>
                   <a:srgbClr val="171717"/>
@@ -10158,6 +10574,7 @@
           <a:lstStyle xmlns:a="http://schemas.openxmlformats.org/drawingml/2006/main"/>
           <a:p xmlns:a="http://schemas.openxmlformats.org/drawingml/2006/main">
             <a:pPr algn="l">
+              <a:buNone/>
               <a:defRPr sz="1425" b="0">
                 <a:solidFill>
                   <a:srgbClr val="677078"/>
@@ -10247,6 +10664,7 @@
           <a:lstStyle xmlns:a="http://schemas.openxmlformats.org/drawingml/2006/main"/>
           <a:p xmlns:a="http://schemas.openxmlformats.org/drawingml/2006/main">
             <a:pPr algn="l">
+              <a:buNone/>
               <a:defRPr sz="900" b="1">
                 <a:solidFill>
                   <a:srgbClr val="FFFFFF"/>
@@ -10305,6 +10723,7 @@
           <a:lstStyle xmlns:a="http://schemas.openxmlformats.org/drawingml/2006/main"/>
           <a:p xmlns:a="http://schemas.openxmlformats.org/drawingml/2006/main">
             <a:pPr algn="l">
+              <a:buNone/>
               <a:defRPr sz="1200" b="1">
                 <a:solidFill>
                   <a:srgbClr val="171717"/>
@@ -10363,6 +10782,7 @@
           <a:lstStyle xmlns:a="http://schemas.openxmlformats.org/drawingml/2006/main"/>
           <a:p xmlns:a="http://schemas.openxmlformats.org/drawingml/2006/main">
             <a:pPr algn="r">
+              <a:buNone/>
               <a:defRPr sz="1350" b="1">
                 <a:solidFill>
                   <a:srgbClr val="00A651"/>
@@ -10421,6 +10841,7 @@
           <a:lstStyle xmlns:a="http://schemas.openxmlformats.org/drawingml/2006/main"/>
           <a:p xmlns:a="http://schemas.openxmlformats.org/drawingml/2006/main">
             <a:pPr algn="l">
+              <a:buNone/>
               <a:defRPr sz="1275" b="1">
                 <a:solidFill>
                   <a:srgbClr val="FF4F12"/>
@@ -10479,6 +10900,7 @@
           <a:lstStyle xmlns:a="http://schemas.openxmlformats.org/drawingml/2006/main"/>
           <a:p xmlns:a="http://schemas.openxmlformats.org/drawingml/2006/main">
             <a:pPr algn="l">
+              <a:buNone/>
               <a:defRPr sz="2250" b="1">
                 <a:solidFill>
                   <a:srgbClr val="171717"/>
@@ -10537,6 +10959,7 @@
           <a:lstStyle xmlns:a="http://schemas.openxmlformats.org/drawingml/2006/main"/>
           <a:p xmlns:a="http://schemas.openxmlformats.org/drawingml/2006/main">
             <a:pPr algn="l">
+              <a:buNone/>
               <a:defRPr sz="1350" b="1">
                 <a:solidFill>
                   <a:srgbClr val="00A651"/>
@@ -10595,6 +11018,7 @@
           <a:lstStyle xmlns:a="http://schemas.openxmlformats.org/drawingml/2006/main"/>
           <a:p xmlns:a="http://schemas.openxmlformats.org/drawingml/2006/main">
             <a:pPr algn="l">
+              <a:buNone/>
               <a:defRPr sz="1725" b="1">
                 <a:solidFill>
                   <a:srgbClr val="171717"/>
@@ -10653,6 +11077,7 @@
           <a:lstStyle xmlns:a="http://schemas.openxmlformats.org/drawingml/2006/main"/>
           <a:p xmlns:a="http://schemas.openxmlformats.org/drawingml/2006/main">
             <a:pPr algn="l">
+              <a:buNone/>
               <a:defRPr sz="1350" b="0">
                 <a:solidFill>
                   <a:srgbClr val="677078"/>
@@ -10742,6 +11167,7 @@
           <a:lstStyle xmlns:a="http://schemas.openxmlformats.org/drawingml/2006/main"/>
           <a:p xmlns:a="http://schemas.openxmlformats.org/drawingml/2006/main">
             <a:pPr algn="l">
+              <a:buNone/>
               <a:defRPr sz="1350" b="1">
                 <a:solidFill>
                   <a:srgbClr val="00A651"/>
@@ -10800,6 +11226,7 @@
           <a:lstStyle xmlns:a="http://schemas.openxmlformats.org/drawingml/2006/main"/>
           <a:p xmlns:a="http://schemas.openxmlformats.org/drawingml/2006/main">
             <a:pPr algn="l">
+              <a:buNone/>
               <a:defRPr sz="1725" b="1">
                 <a:solidFill>
                   <a:srgbClr val="171717"/>
@@ -10858,6 +11285,7 @@
           <a:lstStyle xmlns:a="http://schemas.openxmlformats.org/drawingml/2006/main"/>
           <a:p xmlns:a="http://schemas.openxmlformats.org/drawingml/2006/main">
             <a:pPr algn="l">
+              <a:buNone/>
               <a:defRPr sz="1350" b="0">
                 <a:solidFill>
                   <a:srgbClr val="677078"/>
@@ -10947,6 +11375,7 @@
           <a:lstStyle xmlns:a="http://schemas.openxmlformats.org/drawingml/2006/main"/>
           <a:p xmlns:a="http://schemas.openxmlformats.org/drawingml/2006/main">
             <a:pPr algn="l">
+              <a:buNone/>
               <a:defRPr sz="1350" b="1">
                 <a:solidFill>
                   <a:srgbClr val="00A651"/>
@@ -11005,6 +11434,7 @@
           <a:lstStyle xmlns:a="http://schemas.openxmlformats.org/drawingml/2006/main"/>
           <a:p xmlns:a="http://schemas.openxmlformats.org/drawingml/2006/main">
             <a:pPr algn="l">
+              <a:buNone/>
               <a:defRPr sz="1725" b="1">
                 <a:solidFill>
                   <a:srgbClr val="171717"/>
@@ -11063,6 +11493,7 @@
           <a:lstStyle xmlns:a="http://schemas.openxmlformats.org/drawingml/2006/main"/>
           <a:p xmlns:a="http://schemas.openxmlformats.org/drawingml/2006/main">
             <a:pPr algn="l">
+              <a:buNone/>
               <a:defRPr sz="1350" b="0">
                 <a:solidFill>
                   <a:srgbClr val="677078"/>
@@ -11152,6 +11583,7 @@
           <a:lstStyle xmlns:a="http://schemas.openxmlformats.org/drawingml/2006/main"/>
           <a:p xmlns:a="http://schemas.openxmlformats.org/drawingml/2006/main">
             <a:pPr algn="l">
+              <a:buNone/>
               <a:defRPr sz="1350" b="1">
                 <a:solidFill>
                   <a:srgbClr val="FF4F12"/>
@@ -11210,6 +11642,7 @@
           <a:lstStyle xmlns:a="http://schemas.openxmlformats.org/drawingml/2006/main"/>
           <a:p xmlns:a="http://schemas.openxmlformats.org/drawingml/2006/main">
             <a:pPr algn="l">
+              <a:buNone/>
               <a:defRPr sz="1725" b="1">
                 <a:solidFill>
                   <a:srgbClr val="171717"/>
@@ -11268,6 +11701,7 @@
           <a:lstStyle xmlns:a="http://schemas.openxmlformats.org/drawingml/2006/main"/>
           <a:p xmlns:a="http://schemas.openxmlformats.org/drawingml/2006/main">
             <a:pPr algn="l">
+              <a:buNone/>
               <a:defRPr sz="1350" b="0">
                 <a:solidFill>
                   <a:srgbClr val="677078"/>
@@ -11359,6 +11793,7 @@
           <a:lstStyle xmlns:a="http://schemas.openxmlformats.org/drawingml/2006/main"/>
           <a:p xmlns:a="http://schemas.openxmlformats.org/drawingml/2006/main">
             <a:pPr algn="l">
+              <a:buNone/>
               <a:defRPr sz="1200" b="1">
                 <a:solidFill>
                   <a:srgbClr val="FF4F12"/>
@@ -11417,6 +11852,7 @@
           <a:lstStyle xmlns:a="http://schemas.openxmlformats.org/drawingml/2006/main"/>
           <a:p xmlns:a="http://schemas.openxmlformats.org/drawingml/2006/main">
             <a:pPr algn="ctr">
+              <a:buNone/>
               <a:defRPr sz="1650" b="1">
                 <a:solidFill>
                   <a:srgbClr val="FFFFFF"/>
@@ -11475,6 +11911,7 @@
           <a:lstStyle xmlns:a="http://schemas.openxmlformats.org/drawingml/2006/main"/>
           <a:p xmlns:a="http://schemas.openxmlformats.org/drawingml/2006/main">
             <a:pPr algn="ctr">
+              <a:buNone/>
               <a:defRPr sz="1500" b="1">
                 <a:solidFill>
                   <a:srgbClr val="FF4F12"/>
@@ -11562,6 +11999,7 @@
           <a:lstStyle xmlns:a="http://schemas.openxmlformats.org/drawingml/2006/main"/>
           <a:p xmlns:a="http://schemas.openxmlformats.org/drawingml/2006/main">
             <a:pPr algn="r">
+              <a:buNone/>
               <a:defRPr sz="6450" b="0">
                 <a:solidFill>
                   <a:srgbClr val="F1F2F5"/>
@@ -11620,6 +12058,7 @@
           <a:lstStyle xmlns:a="http://schemas.openxmlformats.org/drawingml/2006/main"/>
           <a:p xmlns:a="http://schemas.openxmlformats.org/drawingml/2006/main">
             <a:pPr algn="l">
+              <a:buNone/>
               <a:defRPr sz="2850" b="1">
                 <a:solidFill>
                   <a:srgbClr val="171717"/>
@@ -11678,6 +12117,7 @@
           <a:lstStyle xmlns:a="http://schemas.openxmlformats.org/drawingml/2006/main"/>
           <a:p xmlns:a="http://schemas.openxmlformats.org/drawingml/2006/main">
             <a:pPr algn="l">
+              <a:buNone/>
               <a:defRPr sz="1425" b="0">
                 <a:solidFill>
                   <a:srgbClr val="677078"/>
@@ -11767,6 +12207,7 @@
           <a:lstStyle xmlns:a="http://schemas.openxmlformats.org/drawingml/2006/main"/>
           <a:p xmlns:a="http://schemas.openxmlformats.org/drawingml/2006/main">
             <a:pPr algn="l">
+              <a:buNone/>
               <a:defRPr sz="900" b="1">
                 <a:solidFill>
                   <a:srgbClr val="FFFFFF"/>
@@ -11825,6 +12266,7 @@
           <a:lstStyle xmlns:a="http://schemas.openxmlformats.org/drawingml/2006/main"/>
           <a:p xmlns:a="http://schemas.openxmlformats.org/drawingml/2006/main">
             <a:pPr algn="l">
+              <a:buNone/>
               <a:defRPr sz="1200" b="1">
                 <a:solidFill>
                   <a:srgbClr val="171717"/>
@@ -11883,6 +12325,7 @@
           <a:lstStyle xmlns:a="http://schemas.openxmlformats.org/drawingml/2006/main"/>
           <a:p xmlns:a="http://schemas.openxmlformats.org/drawingml/2006/main">
             <a:pPr algn="r">
+              <a:buNone/>
               <a:defRPr sz="1350" b="1">
                 <a:solidFill>
                   <a:srgbClr val="00A651"/>
@@ -11941,6 +12384,7 @@
           <a:lstStyle xmlns:a="http://schemas.openxmlformats.org/drawingml/2006/main"/>
           <a:p xmlns:a="http://schemas.openxmlformats.org/drawingml/2006/main">
             <a:pPr algn="l">
+              <a:buNone/>
               <a:defRPr sz="1350" b="1">
                 <a:solidFill>
                   <a:srgbClr val="00A651"/>
@@ -11999,6 +12443,7 @@
           <a:lstStyle xmlns:a="http://schemas.openxmlformats.org/drawingml/2006/main"/>
           <a:p xmlns:a="http://schemas.openxmlformats.org/drawingml/2006/main">
             <a:pPr algn="l">
+              <a:buNone/>
               <a:defRPr sz="2175" b="1">
                 <a:solidFill>
                   <a:srgbClr val="171717"/>
@@ -12022,6 +12467,7 @@
           </a:p>
           <a:p xmlns:a="http://schemas.openxmlformats.org/drawingml/2006/main">
             <a:pPr algn="l">
+              <a:buNone/>
               <a:defRPr sz="2175" b="1">
                 <a:solidFill>
                   <a:srgbClr val="171717"/>
@@ -12080,6 +12526,7 @@
           <a:lstStyle xmlns:a="http://schemas.openxmlformats.org/drawingml/2006/main"/>
           <a:p xmlns:a="http://schemas.openxmlformats.org/drawingml/2006/main">
             <a:pPr algn="l">
+              <a:buNone/>
               <a:defRPr sz="1200" b="1">
                 <a:solidFill>
                   <a:srgbClr val="00A651"/>
@@ -12138,6 +12585,7 @@
           <a:lstStyle xmlns:a="http://schemas.openxmlformats.org/drawingml/2006/main"/>
           <a:p xmlns:a="http://schemas.openxmlformats.org/drawingml/2006/main">
             <a:pPr algn="l">
+              <a:buNone/>
               <a:defRPr sz="1575" b="0">
                 <a:solidFill>
                   <a:srgbClr val="677078"/>
@@ -12227,6 +12675,7 @@
           <a:lstStyle xmlns:a="http://schemas.openxmlformats.org/drawingml/2006/main"/>
           <a:p xmlns:a="http://schemas.openxmlformats.org/drawingml/2006/main">
             <a:pPr algn="l">
+              <a:buNone/>
               <a:defRPr sz="1350" b="1">
                 <a:solidFill>
                   <a:srgbClr val="00A651"/>
@@ -12285,6 +12734,7 @@
           <a:lstStyle xmlns:a="http://schemas.openxmlformats.org/drawingml/2006/main"/>
           <a:p xmlns:a="http://schemas.openxmlformats.org/drawingml/2006/main">
             <a:pPr algn="l">
+              <a:buNone/>
               <a:defRPr sz="2175" b="1">
                 <a:solidFill>
                   <a:srgbClr val="171717"/>
@@ -12308,6 +12758,7 @@
           </a:p>
           <a:p xmlns:a="http://schemas.openxmlformats.org/drawingml/2006/main">
             <a:pPr algn="l">
+              <a:buNone/>
               <a:defRPr sz="2175" b="1">
                 <a:solidFill>
                   <a:srgbClr val="171717"/>
@@ -12366,6 +12817,7 @@
           <a:lstStyle xmlns:a="http://schemas.openxmlformats.org/drawingml/2006/main"/>
           <a:p xmlns:a="http://schemas.openxmlformats.org/drawingml/2006/main">
             <a:pPr algn="l">
+              <a:buNone/>
               <a:defRPr sz="1200" b="1">
                 <a:solidFill>
                   <a:srgbClr val="00A651"/>
@@ -12424,6 +12876,7 @@
           <a:lstStyle xmlns:a="http://schemas.openxmlformats.org/drawingml/2006/main"/>
           <a:p xmlns:a="http://schemas.openxmlformats.org/drawingml/2006/main">
             <a:pPr algn="l">
+              <a:buNone/>
               <a:defRPr sz="1575" b="0">
                 <a:solidFill>
                   <a:srgbClr val="677078"/>
@@ -12513,6 +12966,7 @@
           <a:lstStyle xmlns:a="http://schemas.openxmlformats.org/drawingml/2006/main"/>
           <a:p xmlns:a="http://schemas.openxmlformats.org/drawingml/2006/main">
             <a:pPr algn="l">
+              <a:buNone/>
               <a:defRPr sz="1350" b="1">
                 <a:solidFill>
                   <a:srgbClr val="00A651"/>
@@ -12571,6 +13025,7 @@
           <a:lstStyle xmlns:a="http://schemas.openxmlformats.org/drawingml/2006/main"/>
           <a:p xmlns:a="http://schemas.openxmlformats.org/drawingml/2006/main">
             <a:pPr algn="l">
+              <a:buNone/>
               <a:defRPr sz="2175" b="1">
                 <a:solidFill>
                   <a:srgbClr val="171717"/>
@@ -12594,6 +13049,7 @@
           </a:p>
           <a:p xmlns:a="http://schemas.openxmlformats.org/drawingml/2006/main">
             <a:pPr algn="l">
+              <a:buNone/>
               <a:defRPr sz="2175" b="1">
                 <a:solidFill>
                   <a:srgbClr val="171717"/>
@@ -12652,6 +13108,7 @@
           <a:lstStyle xmlns:a="http://schemas.openxmlformats.org/drawingml/2006/main"/>
           <a:p xmlns:a="http://schemas.openxmlformats.org/drawingml/2006/main">
             <a:pPr algn="l">
+              <a:buNone/>
               <a:defRPr sz="1200" b="1">
                 <a:solidFill>
                   <a:srgbClr val="00A651"/>
@@ -12710,6 +13167,7 @@
           <a:lstStyle xmlns:a="http://schemas.openxmlformats.org/drawingml/2006/main"/>
           <a:p xmlns:a="http://schemas.openxmlformats.org/drawingml/2006/main">
             <a:pPr algn="l">
+              <a:buNone/>
               <a:defRPr sz="1575" b="0">
                 <a:solidFill>
                   <a:srgbClr val="677078"/>
@@ -12801,6 +13259,7 @@
           <a:lstStyle xmlns:a="http://schemas.openxmlformats.org/drawingml/2006/main"/>
           <a:p xmlns:a="http://schemas.openxmlformats.org/drawingml/2006/main">
             <a:pPr algn="ctr">
+              <a:buNone/>
               <a:defRPr sz="1725" b="1">
                 <a:solidFill>
                   <a:srgbClr val="FF4F12"/>
@@ -12859,6 +13318,7 @@
           <a:lstStyle xmlns:a="http://schemas.openxmlformats.org/drawingml/2006/main"/>
           <a:p xmlns:a="http://schemas.openxmlformats.org/drawingml/2006/main">
             <a:pPr algn="ctr">
+              <a:buNone/>
               <a:defRPr sz="1425" b="0">
                 <a:solidFill>
                   <a:srgbClr val="677078"/>

</xml_diff>